<commit_message>
docs: publish latest docs
</commit_message>
<xml_diff>
--- a/latest/macos-app-install/macos-app-install-slides.pptx
+++ b/latest/macos-app-install/macos-app-install-slides.pptx
@@ -5,7 +5,7 @@
     <p:sldMasterId id="2147483648" r:id="rId1"/>
   </p:sldMasterIdLst>
   <p:notesMasterIdLst>
-    <p:notesMasterId r:id="rId12"/>
+    <p:notesMasterId r:id="rId9"/>
   </p:notesMasterIdLst>
   <p:sldIdLst>
     <p:sldId id="256" r:id="rId2"/>
@@ -15,9 +15,6 @@
     <p:sldId id="260" r:id="rId6"/>
     <p:sldId id="261" r:id="rId7"/>
     <p:sldId id="262" r:id="rId8"/>
-    <p:sldId id="263" r:id="rId9"/>
-    <p:sldId id="264" r:id="rId10"/>
-    <p:sldId id="265" r:id="rId11"/>
   </p:sldIdLst>
   <p:sldSz cx="12192000" cy="6858000"/>
   <p:notesSz cx="6858000" cy="12192000"/>
@@ -511,7 +508,7 @@
           <a:p>
             <a:r>
               <a:rPr lang="en-US" dirty="0"/>
-              <a:t>本教程用于 macOS App 首次安装和首启说明。截图来自 mixed-vm-and-rendered-guide-assets-2026-07-03 的中文截图资产。</a:t>
+              <a:t>本教程用于 macOS App 首次安装和首启说明。截图来自 guide-refresh-2026-07-13 的中文截图资产。</a:t>
             </a:r>
             <a:endParaRPr lang="en-US" dirty="0"/>
           </a:p>
@@ -535,94 +532,6 @@
             <a:fld id="{F7021451-1387-4CA6-816F-3879F97B5CBC}" type="slidenum">
               <a:rPr lang="en-US"/>
               <a:t>1</a:t>
-            </a:fld>
-            <a:endParaRPr lang="en-US"/>
-          </a:p>
-        </p:txBody>
-      </p:sp>
-    </p:spTree>
-    <p:extLst>
-      <p:ext uri="{BB962C8B-B14F-4D97-AF65-F5344CB8AC3E}">
-        <p14:creationId xmlns:p14="http://schemas.microsoft.com/office/powerpoint/2010/main" val="1024086991"/>
-      </p:ext>
-    </p:extLst>
-  </p:cSld>
-  <p:clrMapOvr>
-    <a:masterClrMapping/>
-  </p:clrMapOvr>
-</p:notes>
-</file>
-
-<file path=ppt/notesSlides/notesSlide10.xml><?xml version="1.0" encoding="utf-8"?>
-<p:notes xmlns:a="http://schemas.openxmlformats.org/drawingml/2006/main" xmlns:r="http://schemas.openxmlformats.org/officeDocument/2006/relationships" xmlns:p="http://schemas.openxmlformats.org/presentationml/2006/main">
-  <p:cSld>
-    <p:spTree>
-      <p:nvGrpSpPr>
-        <p:cNvPr id="1" name=""/>
-        <p:cNvGrpSpPr/>
-        <p:nvPr/>
-      </p:nvGrpSpPr>
-      <p:grpSpPr>
-        <a:xfrm>
-          <a:off x="0" y="0"/>
-          <a:ext cx="0" cy="0"/>
-          <a:chOff x="0" y="0"/>
-          <a:chExt cx="0" cy="0"/>
-        </a:xfrm>
-      </p:grpSpPr>
-      <p:sp>
-        <p:nvSpPr>
-          <p:cNvPr id="2" name="Slide Image Placeholder 1"/>
-          <p:cNvSpPr>
-            <a:spLocks noGrp="1" noRot="1" noChangeAspect="1"/>
-          </p:cNvSpPr>
-          <p:nvPr>
-            <p:ph type="sldImg"/>
-          </p:nvPr>
-        </p:nvSpPr>
-        <p:spPr/>
-      </p:sp>
-      <p:sp>
-        <p:nvSpPr>
-          <p:cNvPr id="3" name="Notes Placeholder 2"/>
-          <p:cNvSpPr>
-            <a:spLocks noGrp="1"/>
-          </p:cNvSpPr>
-          <p:nvPr>
-            <p:ph type="body" idx="1"/>
-          </p:nvPr>
-        </p:nvSpPr>
-        <p:spPr/>
-        <p:txBody>
-          <a:bodyPr/>
-          <a:lstStyle/>
-          <a:p>
-            <a:r>
-              <a:rPr lang="en-US" dirty="0"/>
-              <a:t>下载失败：换网络后重试，或请技术支持人员确认 GitHub Release 是否可访问。 访问权限未配置：没有可用 Codex 登录、provider 或 OPL Gateway 访问时，向本团队获取 OPL Gateway 访问密钥，并在首启页面或 Settings 中完成配置。 模块未就绪：在本机运行环境或关于与更新中重新检查维护状态。 Release、DMG、首启日志和模块状态以 App repo contracts / workflow / VM smoke artifacts 为机器真相。 截图 manifest 记录来源、语言、尺寸、SHA 和预期中文界面文案。 PPTX/PDF 幻灯片由静态 Marp 编译链路生成，并逐页渲染检查。</a:t>
-            </a:r>
-            <a:endParaRPr lang="en-US" dirty="0"/>
-          </a:p>
-        </p:txBody>
-      </p:sp>
-      <p:sp>
-        <p:nvSpPr>
-          <p:cNvPr id="4" name="Slide Number Placeholder 3"/>
-          <p:cNvSpPr>
-            <a:spLocks noGrp="1"/>
-          </p:cNvSpPr>
-          <p:nvPr>
-            <p:ph type="sldNum" sz="quarter" idx="10"/>
-          </p:nvPr>
-        </p:nvSpPr>
-        <p:spPr/>
-        <p:txBody>
-          <a:bodyPr/>
-          <a:lstStyle/>
-          <a:p>
-            <a:fld id="{F7021451-1387-4CA6-816F-3879F97B5CBC}" type="slidenum">
-              <a:rPr lang="en-US"/>
-              <a:t>10</a:t>
             </a:fld>
             <a:endParaRPr lang="en-US"/>
           </a:p>
@@ -687,7 +596,7 @@
           <a:p>
             <a:r>
               <a:rPr lang="en-US" dirty="0"/>
-              <a:t>访问 One Person Lab App 最新 Release 页面，下载 macOS Apple Silicon DMG。首次安装或干净机器建议选择 Full 版 DMG。 最新版本页面：https://github.com/gaofeng21cn/one-person-lab-app/releases/latest 最简单命令：install.sh --stable-macos-install --yes。 首次安装建议使用 Full 版 DMG。 需要轻量 App 包时可显式选择标准 DMG。</a:t>
+              <a:t>访问最新 Release，在 Assets 区域下载文件名以 mac-arm64.dmg 结尾的安装包。 当前稳定版选择 One-Person-Lab-&lt;版本&gt;-mac-arm64.dmg。 不要下载 ZIP、blockmap 或 Source code。 如果 Release 同时提供 Full，可按页面说明选择；没有 Full 时使用标准 DMG。 页面版本号会持续变化，以最新稳定版为准。</a:t>
             </a:r>
             <a:endParaRPr lang="en-US" dirty="0"/>
           </a:p>
@@ -775,7 +684,7 @@
           <a:p>
             <a:r>
               <a:rPr lang="en-US" dirty="0"/>
-              <a:t>打开 DMG，将 One Person Lab 拖入 Applications。首次打开如出现 macOS 安全提示，按系统提示确认。 安装完成后从 Applications 启动 App。 不要长期在 DMG 挂载窗口内运行 App。</a:t>
+              <a:t>打开 DMG，将 One Person Lab 拖入 Applications。复制完成后从“应用程序”启动。 首次打开如有安全提示，按系统提示确认。 不要长期在 DMG 挂载窗口内运行 App。</a:t>
             </a:r>
             <a:endParaRPr lang="en-US" dirty="0"/>
           </a:p>
@@ -863,7 +772,7 @@
           <a:p>
             <a:r>
               <a:rPr lang="en-US" dirty="0"/>
-              <a:t>首次启动会先检查模型访问；已有可用 Codex/OpenAI 登录或其它 provider 时，可先跳过 OPL Gateway 配置。完全没有可用模型访问时，可向本团队获取 OPL Gateway 访问密钥，并在首启页面完成配置。 拿到访问密钥后，在页面输入 OPL Gateway 访问密钥。 点击配置 OPL Gateway 后继续首启检查；跳过的用户之后仍可在 Settings 中切换到 OPL Gateway。 不要截图、转发或保存密钥到研究目录。</a:t>
+              <a:t>已有可用 Codex/OpenAI 登录或其他模型配置时，继续使用现有配置；没有可用模型来源或需要团队统一访问时，再配置 OPL Gateway。 已有配置：选择“已有 Codex 配置”，点击“重新检测已有配置”。 使用 Gateway：向本团队获取访问密钥，粘贴后完成配置。 暂不配置：先进入 OPL，之后从“设置 -&gt; 模型与访问”继续。</a:t>
             </a:r>
             <a:endParaRPr lang="en-US" dirty="0"/>
           </a:p>
@@ -951,7 +860,7 @@
           <a:p>
             <a:r>
               <a:rPr lang="en-US" dirty="0"/>
-              <a:t>OPL 会先检查开始使用所需的关键项：工作目录、本机助手和访问权限。 首屏只显示“正在准备 / 可以开始 / 需要处理”的简短状态。 技术 phase、刷新和原始错误默认收在技术细节里。 遇到阻塞时先阅读界面提示。</a:t>
+              <a:t>OPL 会检查工作目录、本机助手和模型访问，并显示当前进度和下一步。 检查期间可以先进入主界面，但不会自动完成尚未配置的项目。 出现“需要处理”时，按页面给出的下一步操作。 普通用户不需要理解折叠在“技术细节”中的底层工具。</a:t>
             </a:r>
             <a:endParaRPr lang="en-US" dirty="0"/>
           </a:p>
@@ -1039,7 +948,7 @@
           <a:p>
             <a:r>
               <a:rPr lang="en-US" dirty="0"/>
-              <a:t>准备完成后，根据目标选择科研、基金、演示或写书入口。本教程以科研入口为例。 通过 Research Foundry / Med Auto Science 进入 MAS。 基金、演示和写书入口分别对应 MAG、RCA 和 BookForge。 用户不需要另行获取这些专业 Agent 的分发资产。</a:t>
+              <a:t>进入主界面后，直接描述目标，或选择科研、基金、演示、写书等专业入口。 第一条任务同时说明目标和材料位置。 涉及患者或敏感数据时，先完成脱敏并遵守机构要求。 更换模型访问方式时，打开“设置 -&gt; 模型与访问”。</a:t>
             </a:r>
             <a:endParaRPr lang="en-US" dirty="0"/>
           </a:p>
@@ -1127,7 +1036,7 @@
           <a:p>
             <a:r>
               <a:rPr lang="en-US" dirty="0"/>
-              <a:t>在本机运行环境中确认工作目录、Codex CLI、Temporal 和本机基础状态。 数据目录和运行入口从 Settings 的本机运行环境进入。 专业 Agent 能力在智能体与能力中查看。 App 与 OPL Packages 维护状态在关于与更新中查看。 患者数据需先脱敏，并遵守机构要求。</a:t>
+              <a:t>已有 Codex 配置：不需要先配置 OPL Gateway。 暂时没有 Gateway 密钥：可以先进入 OPL，后续再配置。 下载文件很多：选择文件名以 mac-arm64.dmg 结尾的安装包。 打不开 App：确认已复制到 Applications，并按 macOS 安全提示允许打开。 密钥无法使用：确认复制完整、密钥仍启用；反馈截图必须遮挡密钥。 更换模型访问方式：打开“设置 -&gt; 模型与访问”。 检查 App 更新：打开“设置 -&gt; 关于与更新”。 涉及患者或敏感研究数据时，先完成脱敏并遵守机构要求。</a:t>
             </a:r>
             <a:endParaRPr lang="en-US" dirty="0"/>
           </a:p>
@@ -1151,182 +1060,6 @@
             <a:fld id="{F7021451-1387-4CA6-816F-3879F97B5CBC}" type="slidenum">
               <a:rPr lang="en-US"/>
               <a:t>7</a:t>
-            </a:fld>
-            <a:endParaRPr lang="en-US"/>
-          </a:p>
-        </p:txBody>
-      </p:sp>
-    </p:spTree>
-    <p:extLst>
-      <p:ext uri="{BB962C8B-B14F-4D97-AF65-F5344CB8AC3E}">
-        <p14:creationId xmlns:p14="http://schemas.microsoft.com/office/powerpoint/2010/main" val="1024086991"/>
-      </p:ext>
-    </p:extLst>
-  </p:cSld>
-  <p:clrMapOvr>
-    <a:masterClrMapping/>
-  </p:clrMapOvr>
-</p:notes>
-</file>
-
-<file path=ppt/notesSlides/notesSlide8.xml><?xml version="1.0" encoding="utf-8"?>
-<p:notes xmlns:a="http://schemas.openxmlformats.org/drawingml/2006/main" xmlns:r="http://schemas.openxmlformats.org/officeDocument/2006/relationships" xmlns:p="http://schemas.openxmlformats.org/presentationml/2006/main">
-  <p:cSld>
-    <p:spTree>
-      <p:nvGrpSpPr>
-        <p:cNvPr id="1" name=""/>
-        <p:cNvGrpSpPr/>
-        <p:nvPr/>
-      </p:nvGrpSpPr>
-      <p:grpSpPr>
-        <a:xfrm>
-          <a:off x="0" y="0"/>
-          <a:ext cx="0" cy="0"/>
-          <a:chOff x="0" y="0"/>
-          <a:chExt cx="0" cy="0"/>
-        </a:xfrm>
-      </p:grpSpPr>
-      <p:sp>
-        <p:nvSpPr>
-          <p:cNvPr id="2" name="Slide Image Placeholder 1"/>
-          <p:cNvSpPr>
-            <a:spLocks noGrp="1" noRot="1" noChangeAspect="1"/>
-          </p:cNvSpPr>
-          <p:nvPr>
-            <p:ph type="sldImg"/>
-          </p:nvPr>
-        </p:nvSpPr>
-        <p:spPr/>
-      </p:sp>
-      <p:sp>
-        <p:nvSpPr>
-          <p:cNvPr id="3" name="Notes Placeholder 2"/>
-          <p:cNvSpPr>
-            <a:spLocks noGrp="1"/>
-          </p:cNvSpPr>
-          <p:nvPr>
-            <p:ph type="body" idx="1"/>
-          </p:nvPr>
-        </p:nvSpPr>
-        <p:spPr/>
-        <p:txBody>
-          <a:bodyPr/>
-          <a:lstStyle/>
-          <a:p>
-            <a:r>
-              <a:rPr lang="en-US" dirty="0"/>
-              <a:t>第一条任务可直接用自然语言描述，让 MAS 先判断研究方向、证据缺口和下一步。 示例提示词写清数据类型、workspace、原始材料位置和目标产物。 我有一批肺结节随访数据，专病 workspace 在“肺结节真实世界研究”，原始材料在 raw_data/，请先判断最值得推进的研究问题，并说明还缺哪些证据，目标是形成一篇可投稿论文。</a:t>
-            </a:r>
-            <a:endParaRPr lang="en-US" dirty="0"/>
-          </a:p>
-        </p:txBody>
-      </p:sp>
-      <p:sp>
-        <p:nvSpPr>
-          <p:cNvPr id="4" name="Slide Number Placeholder 3"/>
-          <p:cNvSpPr>
-            <a:spLocks noGrp="1"/>
-          </p:cNvSpPr>
-          <p:nvPr>
-            <p:ph type="sldNum" sz="quarter" idx="10"/>
-          </p:nvPr>
-        </p:nvSpPr>
-        <p:spPr/>
-        <p:txBody>
-          <a:bodyPr/>
-          <a:lstStyle/>
-          <a:p>
-            <a:fld id="{F7021451-1387-4CA6-816F-3879F97B5CBC}" type="slidenum">
-              <a:rPr lang="en-US"/>
-              <a:t>8</a:t>
-            </a:fld>
-            <a:endParaRPr lang="en-US"/>
-          </a:p>
-        </p:txBody>
-      </p:sp>
-    </p:spTree>
-    <p:extLst>
-      <p:ext uri="{BB962C8B-B14F-4D97-AF65-F5344CB8AC3E}">
-        <p14:creationId xmlns:p14="http://schemas.microsoft.com/office/powerpoint/2010/main" val="1024086991"/>
-      </p:ext>
-    </p:extLst>
-  </p:cSld>
-  <p:clrMapOvr>
-    <a:masterClrMapping/>
-  </p:clrMapOvr>
-</p:notes>
-</file>
-
-<file path=ppt/notesSlides/notesSlide9.xml><?xml version="1.0" encoding="utf-8"?>
-<p:notes xmlns:a="http://schemas.openxmlformats.org/drawingml/2006/main" xmlns:r="http://schemas.openxmlformats.org/officeDocument/2006/relationships" xmlns:p="http://schemas.openxmlformats.org/presentationml/2006/main">
-  <p:cSld>
-    <p:spTree>
-      <p:nvGrpSpPr>
-        <p:cNvPr id="1" name=""/>
-        <p:cNvGrpSpPr/>
-        <p:nvPr/>
-      </p:nvGrpSpPr>
-      <p:grpSpPr>
-        <a:xfrm>
-          <a:off x="0" y="0"/>
-          <a:ext cx="0" cy="0"/>
-          <a:chOff x="0" y="0"/>
-          <a:chExt cx="0" cy="0"/>
-        </a:xfrm>
-      </p:grpSpPr>
-      <p:sp>
-        <p:nvSpPr>
-          <p:cNvPr id="2" name="Slide Image Placeholder 1"/>
-          <p:cNvSpPr>
-            <a:spLocks noGrp="1" noRot="1" noChangeAspect="1"/>
-          </p:cNvSpPr>
-          <p:nvPr>
-            <p:ph type="sldImg"/>
-          </p:nvPr>
-        </p:nvSpPr>
-        <p:spPr/>
-      </p:sp>
-      <p:sp>
-        <p:nvSpPr>
-          <p:cNvPr id="3" name="Notes Placeholder 2"/>
-          <p:cNvSpPr>
-            <a:spLocks noGrp="1"/>
-          </p:cNvSpPr>
-          <p:nvPr>
-            <p:ph type="body" idx="1"/>
-          </p:nvPr>
-        </p:nvSpPr>
-        <p:spPr/>
-        <p:txBody>
-          <a:bodyPr/>
-          <a:lstStyle/>
-          <a:p>
-            <a:r>
-              <a:rPr lang="en-US" dirty="0"/>
-              <a:t>任务启动后，重点查看当前阶段、阻塞项、下一步和产物位置。 看到人工确认项时，由研究者或 PI 判断。 投稿前科学判断、伦理合规和署名仍由团队负责。</a:t>
-            </a:r>
-            <a:endParaRPr lang="en-US" dirty="0"/>
-          </a:p>
-        </p:txBody>
-      </p:sp>
-      <p:sp>
-        <p:nvSpPr>
-          <p:cNvPr id="4" name="Slide Number Placeholder 3"/>
-          <p:cNvSpPr>
-            <a:spLocks noGrp="1"/>
-          </p:cNvSpPr>
-          <p:nvPr>
-            <p:ph type="sldNum" sz="quarter" idx="10"/>
-          </p:nvPr>
-        </p:nvSpPr>
-        <p:spPr/>
-        <p:txBody>
-          <a:bodyPr/>
-          <a:lstStyle/>
-          <a:p>
-            <a:fld id="{F7021451-1387-4CA6-816F-3879F97B5CBC}" type="slidenum">
-              <a:rPr lang="en-US"/>
-              <a:t>9</a:t>
             </a:fld>
             <a:endParaRPr lang="en-US"/>
           </a:p>
@@ -1655,45 +1388,6 @@
 <file path=ppt/slides/slide1.xml><?xml version="1.0" encoding="utf-8"?>
 <p:sld xmlns:a="http://schemas.openxmlformats.org/drawingml/2006/main" xmlns:r="http://schemas.openxmlformats.org/officeDocument/2006/relationships" xmlns:p="http://schemas.openxmlformats.org/presentationml/2006/main">
   <p:cSld name="Slide 1">
-    <p:bg>
-      <p:bgPr>
-        <a:blipFill dpi="0" rotWithShape="1">
-          <a:blip r:embed="rId1">
-            <a:lum/>
-          </a:blip>
-          <a:srcRect/>
-          <a:stretch>
-            <a:fillRect/>
-          </a:stretch>
-        </a:blipFill>
-        <a:effectLst/>
-      </p:bgPr>
-    </p:bg>
-    <p:spTree>
-      <p:nvGrpSpPr>
-        <p:cNvPr id="1" name=""/>
-        <p:cNvGrpSpPr/>
-        <p:nvPr/>
-      </p:nvGrpSpPr>
-      <p:grpSpPr>
-        <a:xfrm>
-          <a:off x="0" y="0"/>
-          <a:ext cx="0" cy="0"/>
-          <a:chOff x="0" y="0"/>
-          <a:chExt cx="0" cy="0"/>
-        </a:xfrm>
-      </p:grpSpPr>
-    </p:spTree>
-  </p:cSld>
-  <p:clrMapOvr>
-    <a:masterClrMapping/>
-  </p:clrMapOvr>
-</p:sld>
-</file>
-
-<file path=ppt/slides/slide10.xml><?xml version="1.0" encoding="utf-8"?>
-<p:sld xmlns:a="http://schemas.openxmlformats.org/drawingml/2006/main" xmlns:r="http://schemas.openxmlformats.org/officeDocument/2006/relationships" xmlns:p="http://schemas.openxmlformats.org/presentationml/2006/main">
-  <p:cSld name="Slide 10">
     <p:bg>
       <p:bgPr>
         <a:blipFill dpi="0" rotWithShape="1">
@@ -1964,84 +1658,6 @@
 </p:sld>
 </file>
 
-<file path=ppt/slides/slide8.xml><?xml version="1.0" encoding="utf-8"?>
-<p:sld xmlns:a="http://schemas.openxmlformats.org/drawingml/2006/main" xmlns:r="http://schemas.openxmlformats.org/officeDocument/2006/relationships" xmlns:p="http://schemas.openxmlformats.org/presentationml/2006/main">
-  <p:cSld name="Slide 8">
-    <p:bg>
-      <p:bgPr>
-        <a:blipFill dpi="0" rotWithShape="1">
-          <a:blip r:embed="rId1">
-            <a:lum/>
-          </a:blip>
-          <a:srcRect/>
-          <a:stretch>
-            <a:fillRect/>
-          </a:stretch>
-        </a:blipFill>
-        <a:effectLst/>
-      </p:bgPr>
-    </p:bg>
-    <p:spTree>
-      <p:nvGrpSpPr>
-        <p:cNvPr id="1" name=""/>
-        <p:cNvGrpSpPr/>
-        <p:nvPr/>
-      </p:nvGrpSpPr>
-      <p:grpSpPr>
-        <a:xfrm>
-          <a:off x="0" y="0"/>
-          <a:ext cx="0" cy="0"/>
-          <a:chOff x="0" y="0"/>
-          <a:chExt cx="0" cy="0"/>
-        </a:xfrm>
-      </p:grpSpPr>
-    </p:spTree>
-  </p:cSld>
-  <p:clrMapOvr>
-    <a:masterClrMapping/>
-  </p:clrMapOvr>
-</p:sld>
-</file>
-
-<file path=ppt/slides/slide9.xml><?xml version="1.0" encoding="utf-8"?>
-<p:sld xmlns:a="http://schemas.openxmlformats.org/drawingml/2006/main" xmlns:r="http://schemas.openxmlformats.org/officeDocument/2006/relationships" xmlns:p="http://schemas.openxmlformats.org/presentationml/2006/main">
-  <p:cSld name="Slide 9">
-    <p:bg>
-      <p:bgPr>
-        <a:blipFill dpi="0" rotWithShape="1">
-          <a:blip r:embed="rId1">
-            <a:lum/>
-          </a:blip>
-          <a:srcRect/>
-          <a:stretch>
-            <a:fillRect/>
-          </a:stretch>
-        </a:blipFill>
-        <a:effectLst/>
-      </p:bgPr>
-    </p:bg>
-    <p:spTree>
-      <p:nvGrpSpPr>
-        <p:cNvPr id="1" name=""/>
-        <p:cNvGrpSpPr/>
-        <p:nvPr/>
-      </p:nvGrpSpPr>
-      <p:grpSpPr>
-        <a:xfrm>
-          <a:off x="0" y="0"/>
-          <a:ext cx="0" cy="0"/>
-          <a:chOff x="0" y="0"/>
-          <a:chExt cx="0" cy="0"/>
-        </a:xfrm>
-      </p:grpSpPr>
-    </p:spTree>
-  </p:cSld>
-  <p:clrMapOvr>
-    <a:masterClrMapping/>
-  </p:clrMapOvr>
-</p:sld>
-</file>
-
 <file path=ppt/theme/theme1.xml><?xml version="1.0" encoding="utf-8"?>
 <a:theme xmlns:a="http://schemas.openxmlformats.org/drawingml/2006/main" name="Office Theme">
   <a:themeElements>

</xml_diff>